<commit_message>
docs(ui): progress deck, the owner's edits
Co-Authored-By: Claude Opus 5.5 (1M context) <noreply@anthropic.com>
</commit_message>
<xml_diff>
--- a/docs/ui-docs/dast-ui-progress.pptx
+++ b/docs/ui-docs/dast-ui-progress.pptx
@@ -19,6 +19,7 @@
     <p:sldId id="267" r:id="rId13"/>
     <p:sldId id="268" r:id="rId14"/>
     <p:sldId id="269" r:id="rId15"/>
+    <p:sldId id="285" r:id="rId36"/>
     <p:sldId id="270" r:id="rId16"/>
     <p:sldId id="271" r:id="rId17"/>
     <p:sldId id="272" r:id="rId18"/>
@@ -29,6 +30,7 @@
     <p:sldId id="277" r:id="rId23"/>
     <p:sldId id="278" r:id="rId24"/>
     <p:sldId id="279" r:id="rId25"/>
+    <p:sldId id="286" r:id="rId37"/>
     <p:sldId id="280" r:id="rId26"/>
     <p:sldId id="281" r:id="rId27"/>
     <p:sldId id="282" r:id="rId28"/>
@@ -1299,7 +1301,7 @@
           <a:p>
             <a:r>
               <a:rPr lang="en-US" dirty="0"/>
-              <a:t>Environment prep, not configuration: DVWA's database was created once (its /setup.php), and DVWA_USER/DVWA_PASS were set in the shell that started the UI. The repository's hand-tuned DVWA config was moved aside first.</a:t>
+              <a:t>Step 0, on the right: the scanner never gets a copy of the app. DVWA is the public vulnerables/web-dvwa image, pinned in compose.yaml and run as a container on the same Docker network as ZAP, which reaches it as http://dvwa. Environment prep, not configuration: DVWA's database was created once (its /setup.php), and DVWA_USER/DVWA_PASS were set in the shell that started the UI. The repository's hand-tuned DVWA config was moved aside first.</a:t>
             </a:r>
             <a:endParaRPr lang="en-US" dirty="0"/>
           </a:p>
@@ -1387,7 +1389,7 @@
           <a:p>
             <a:r>
               <a:rPr lang="en-US" dirty="0"/>
-              <a:t>Times are measured by the headless browser that drove the UI. Steps 1-3 total 58 s from opening Onboard to a finished first scan; the whole first pass including triage, publish preview, workflow and governance took 86 s. Step 4 is on the next-but-four slide, “5 · Two edits”.</a:t>
+              <a:t>Times are measured by the headless browser that drove the UI. Steps 1-3 total 58 s from opening Onboard to a finished first scan; the whole first pass including triage, publish preview, workflow and governance took 86 s. The setup on the two slides before is not timed. Step 4 is on the next-but-four slide, “5 · Two edits”.</a:t>
             </a:r>
             <a:endParaRPr lang="en-US" dirty="0"/>
           </a:p>
@@ -2819,6 +2821,182 @@
             <a:fld id="{F7021451-1387-4CA6-816F-3879F97B5CBC}" type="slidenum">
               <a:rPr lang="en-US"/>
               <a:t>3</a:t>
+            </a:fld>
+            <a:endParaRPr lang="en-US"/>
+          </a:p>
+        </p:txBody>
+      </p:sp>
+    </p:spTree>
+    <p:extLst>
+      <p:ext uri="{BB962C8B-B14F-4D97-AF65-F5344CB8AC3E}">
+        <p14:creationId xmlns:p14="http://schemas.microsoft.com/office/powerpoint/2010/main" val="1024086991"/>
+      </p:ext>
+    </p:extLst>
+  </p:cSld>
+  <p:clrMapOvr>
+    <a:masterClrMapping/>
+  </p:clrMapOvr>
+</p:notes>
+</file>
+
+<file path=ppt/notesSlides/notesSlide30.xml><?xml version="1.0" encoding="utf-8"?>
+<p:notes xmlns:a="http://schemas.openxmlformats.org/drawingml/2006/main" xmlns:r="http://schemas.openxmlformats.org/officeDocument/2006/relationships" xmlns:p="http://schemas.openxmlformats.org/presentationml/2006/main">
+  <p:cSld>
+    <p:spTree>
+      <p:nvGrpSpPr>
+        <p:cNvPr id="1" name=""/>
+        <p:cNvGrpSpPr/>
+        <p:nvPr/>
+      </p:nvGrpSpPr>
+      <p:grpSpPr>
+        <a:xfrm>
+          <a:off x="0" y="0"/>
+          <a:ext cx="0" cy="0"/>
+          <a:chOff x="0" y="0"/>
+          <a:chExt cx="0" cy="0"/>
+        </a:xfrm>
+      </p:grpSpPr>
+      <p:sp>
+        <p:nvSpPr>
+          <p:cNvPr id="2" name="Slide Image Placeholder 1"/>
+          <p:cNvSpPr>
+            <a:spLocks noGrp="1" noRot="1" noChangeAspect="1"/>
+          </p:cNvSpPr>
+          <p:nvPr>
+            <p:ph type="sldImg"/>
+          </p:nvPr>
+        </p:nvSpPr>
+        <p:spPr/>
+      </p:sp>
+      <p:sp>
+        <p:nvSpPr>
+          <p:cNvPr id="3" name="Notes Placeholder 2"/>
+          <p:cNvSpPr>
+            <a:spLocks noGrp="1"/>
+          </p:cNvSpPr>
+          <p:nvPr>
+            <p:ph type="body" idx="1"/>
+          </p:nvPr>
+        </p:nvSpPr>
+        <p:spPr/>
+        <p:txBody>
+          <a:bodyPr/>
+          <a:lstStyle/>
+          <a:p>
+            <a:r>
+              <a:rPr lang="en-US" dirty="0"/>
+              <a:t>Prep that a person does once, before onboarding; none of it is in the 58 s. Sources: docs/onboarding_a_new_application.md §1 and docs/ui-docs/ui_demo.md. ZAP_API_KEY must be the key ZAP was started with: a test or staging scan refuses an open ZAP API.</a:t>
+            </a:r>
+            <a:endParaRPr lang="en-US" dirty="0"/>
+          </a:p>
+        </p:txBody>
+      </p:sp>
+      <p:sp>
+        <p:nvSpPr>
+          <p:cNvPr id="4" name="Slide Number Placeholder 3"/>
+          <p:cNvSpPr>
+            <a:spLocks noGrp="1"/>
+          </p:cNvSpPr>
+          <p:nvPr>
+            <p:ph type="sldNum" sz="quarter" idx="10"/>
+          </p:nvPr>
+        </p:nvSpPr>
+        <p:spPr/>
+        <p:txBody>
+          <a:bodyPr/>
+          <a:lstStyle/>
+          <a:p>
+            <a:fld id="{F7021451-1387-4CA6-816F-3879F97B5CBC}" type="slidenum">
+              <a:rPr lang="en-US"/>
+              <a:t>25</a:t>
+            </a:fld>
+            <a:endParaRPr lang="en-US"/>
+          </a:p>
+        </p:txBody>
+      </p:sp>
+    </p:spTree>
+    <p:extLst>
+      <p:ext uri="{BB962C8B-B14F-4D97-AF65-F5344CB8AC3E}">
+        <p14:creationId xmlns:p14="http://schemas.microsoft.com/office/powerpoint/2010/main" val="1024086991"/>
+      </p:ext>
+    </p:extLst>
+  </p:cSld>
+  <p:clrMapOvr>
+    <a:masterClrMapping/>
+  </p:clrMapOvr>
+</p:notes>
+</file>
+
+<file path=ppt/notesSlides/notesSlide31.xml><?xml version="1.0" encoding="utf-8"?>
+<p:notes xmlns:a="http://schemas.openxmlformats.org/drawingml/2006/main" xmlns:r="http://schemas.openxmlformats.org/officeDocument/2006/relationships" xmlns:p="http://schemas.openxmlformats.org/presentationml/2006/main">
+  <p:cSld>
+    <p:spTree>
+      <p:nvGrpSpPr>
+        <p:cNvPr id="1" name=""/>
+        <p:cNvGrpSpPr/>
+        <p:nvPr/>
+      </p:nvGrpSpPr>
+      <p:grpSpPr>
+        <a:xfrm>
+          <a:off x="0" y="0"/>
+          <a:ext cx="0" cy="0"/>
+          <a:chOff x="0" y="0"/>
+          <a:chExt cx="0" cy="0"/>
+        </a:xfrm>
+      </p:grpSpPr>
+      <p:sp>
+        <p:nvSpPr>
+          <p:cNvPr id="2" name="Slide Image Placeholder 1"/>
+          <p:cNvSpPr>
+            <a:spLocks noGrp="1" noRot="1" noChangeAspect="1"/>
+          </p:cNvSpPr>
+          <p:nvPr>
+            <p:ph type="sldImg"/>
+          </p:nvPr>
+        </p:nvSpPr>
+        <p:spPr/>
+      </p:sp>
+      <p:sp>
+        <p:nvSpPr>
+          <p:cNvPr id="3" name="Notes Placeholder 2"/>
+          <p:cNvSpPr>
+            <a:spLocks noGrp="1"/>
+          </p:cNvSpPr>
+          <p:nvPr>
+            <p:ph type="body" idx="1"/>
+          </p:nvPr>
+        </p:nvSpPr>
+        <p:spPr/>
+        <p:txBody>
+          <a:bodyPr/>
+          <a:lstStyle/>
+          <a:p>
+            <a:r>
+              <a:rPr lang="en-US" dirty="0"/>
+              <a:t>Every UI screen runs these commands and shows them in its command-line panel. Each command is prefixed python -m. Details: docs/onboarding_a_new_application.md §2 (onboard) and §4 (author, scan, report).</a:t>
+            </a:r>
+            <a:endParaRPr lang="en-US" dirty="0"/>
+          </a:p>
+        </p:txBody>
+      </p:sp>
+      <p:sp>
+        <p:nvSpPr>
+          <p:cNvPr id="4" name="Slide Number Placeholder 3"/>
+          <p:cNvSpPr>
+            <a:spLocks noGrp="1"/>
+          </p:cNvSpPr>
+          <p:nvPr>
+            <p:ph type="sldNum" sz="quarter" idx="10"/>
+          </p:nvPr>
+        </p:nvSpPr>
+        <p:spPr/>
+        <p:txBody>
+          <a:bodyPr/>
+          <a:lstStyle/>
+          <a:p>
+            <a:fld id="{F7021451-1387-4CA6-816F-3879F97B5CBC}" type="slidenum">
+              <a:rPr lang="en-US"/>
+              <a:t>25</a:t>
             </a:fld>
             <a:endParaRPr lang="en-US"/>
           </a:p>
@@ -6111,9 +6289,185 @@
                   <a:srgbClr val="C6D3DC"/>
                 </a:solidFill>
               </a:rPr>
-              <a:t>Onboarded through the UI alone on 22 October, against its own isolated ZAP. Nothing about DVWA was configured beforehand; every screenshot is from that run.</a:t>
+              <a:t>Onboarded through the UI alone on 22 October, against its own isolated ZAP. Nothing about DVWA was configured in the tool beforehand; every screenshot is from that run.</a:t>
             </a:r>
             <a:endParaRPr lang="en-US" sz="1800" dirty="0"/>
+          </a:p>
+        </p:txBody>
+      </p:sp>
+      <p:sp>
+        <p:nvSpPr>
+          <p:cNvPr id="30" name="Step 0 panel"/>
+          <p:cNvSpPr/>
+          <p:nvPr/>
+        </p:nvSpPr>
+        <p:spPr>
+          <a:xfrm>
+            <a:off x="7086600" y="1463040"/>
+            <a:ext cx="4526280" cy="3611880"/>
+          </a:xfrm>
+          <a:prstGeom prst="roundRect">
+            <a:avLst>
+              <a:gd name="adj" fmla="val 4000"/>
+            </a:avLst>
+          </a:prstGeom>
+          <a:solidFill>
+            <a:schemeClr val="bg1">
+              <a:alpha val="9000"/>
+            </a:schemeClr>
+          </a:solidFill>
+          <a:ln>
+            <a:noFill/>
+          </a:ln>
+        </p:spPr>
+      </p:sp>
+      <p:sp>
+        <p:nvSpPr>
+          <p:cNvPr id="31" name="Step 0 heading"/>
+          <p:cNvSpPr txBox="1"/>
+          <p:nvPr/>
+        </p:nvSpPr>
+        <p:spPr>
+          <a:xfrm>
+            <a:off x="7360920" y="1737360"/>
+            <a:ext cx="3977640" cy="548640"/>
+          </a:xfrm>
+          <a:prstGeom prst="rect">
+            <a:avLst/>
+          </a:prstGeom>
+          <a:noFill/>
+          <a:ln/>
+        </p:spPr>
+        <p:txBody>
+          <a:bodyPr wrap="square" lIns="0" tIns="0" rIns="0" bIns="0" rtlCol="0" anchor="t"/>
+          <a:lstStyle/>
+          <a:p>
+            <a:pPr indent="0" marL="0">
+              <a:buNone/>
+            </a:pPr>
+            <a:r>
+              <a:rPr lang="en-US" sz="1700" b="1" dirty="0">
+                <a:solidFill>
+                  <a:schemeClr val="bg1"/>
+                </a:solidFill>
+              </a:rPr>
+              <a:t>0 · Before onboarding: put the app where ZAP can reach it</a:t>
+            </a:r>
+          </a:p>
+        </p:txBody>
+      </p:sp>
+      <p:sp>
+        <p:nvSpPr>
+          <p:cNvPr id="32" name="Step 0 items"/>
+          <p:cNvSpPr txBox="1"/>
+          <p:nvPr/>
+        </p:nvSpPr>
+        <p:spPr>
+          <a:xfrm>
+            <a:off x="7360920" y="2423160"/>
+            <a:ext cx="3977640" cy="2377440"/>
+          </a:xfrm>
+          <a:prstGeom prst="rect">
+            <a:avLst/>
+          </a:prstGeom>
+          <a:noFill/>
+          <a:ln/>
+        </p:spPr>
+        <p:txBody>
+          <a:bodyPr wrap="square" lIns="0" tIns="0" rIns="0" bIns="0" rtlCol="0" anchor="t"/>
+          <a:lstStyle/>
+          <a:p>
+            <a:pPr indent="0" marL="0">
+              <a:spcAft>
+                <a:spcPts val="900"/>
+              </a:spcAft>
+              <a:buNone/>
+            </a:pPr>
+            <a:r>
+              <a:rPr lang="en-US" sz="1300" b="1" dirty="0">
+                <a:solidFill>
+                  <a:schemeClr val="bg1"/>
+                </a:solidFill>
+              </a:rPr>
+              <a:t>Nothing is uploaded. </a:t>
+            </a:r>
+            <a:r>
+              <a:rPr lang="en-US" sz="1300" dirty="0">
+                <a:solidFill>
+                  <a:srgbClr val="C6D3DC"/>
+                </a:solidFill>
+              </a:rPr>
+              <a:t>ZAP never receives the app: it sends traffic over the network to a copy that is already running.</a:t>
+            </a:r>
+          </a:p>
+          <a:p>
+            <a:pPr indent="0" marL="0">
+              <a:spcAft>
+                <a:spcPts val="900"/>
+              </a:spcAft>
+              <a:buNone/>
+            </a:pPr>
+            <a:r>
+              <a:rPr lang="en-US" sz="1300" b="1" dirty="0">
+                <a:solidFill>
+                  <a:schemeClr val="bg1"/>
+                </a:solidFill>
+              </a:rPr>
+              <a:t>The image. </a:t>
+            </a:r>
+            <a:r>
+              <a:rPr lang="en-US" sz="1300" dirty="0">
+                <a:solidFill>
+                  <a:srgbClr val="C6D3DC"/>
+                </a:solidFill>
+              </a:rPr>
+              <a:t>The public vulnerables/web-dvwa from Docker Hub, pinned by digest in compose.yaml (DVWA_IMAGE points at a mirror).</a:t>
+            </a:r>
+          </a:p>
+          <a:p>
+            <a:pPr indent="0" marL="0">
+              <a:spcAft>
+                <a:spcPts val="900"/>
+              </a:spcAft>
+              <a:buNone/>
+            </a:pPr>
+            <a:r>
+              <a:rPr lang="en-US" sz="1300" b="1" dirty="0">
+                <a:solidFill>
+                  <a:schemeClr val="bg1"/>
+                </a:solidFill>
+              </a:rPr>
+              <a:t>Where it runs. </a:t>
+            </a:r>
+            <a:r>
+              <a:rPr lang="en-US" sz="1300" dirty="0">
+                <a:solidFill>
+                  <a:srgbClr val="C6D3DC"/>
+                </a:solidFill>
+              </a:rPr>
+              <a:t>A container on the dast Docker network beside ZAP, at http://dvwa: the name ZAP resolves, not localhost. Never port 8080, which is ZAP's own.</a:t>
+            </a:r>
+          </a:p>
+          <a:p>
+            <a:pPr indent="0" marL="0">
+              <a:buNone/>
+            </a:pPr>
+            <a:r>
+              <a:rPr lang="en-US" sz="1300" b="1" dirty="0">
+                <a:solidFill>
+                  <a:schemeClr val="bg1"/>
+                </a:solidFill>
+              </a:rPr>
+              <a:t>Check it. </a:t>
+            </a:r>
+            <a:r>
+              <a:rPr lang="en-US" sz="1300" dirty="0">
+                <a:solidFill>
+                  <a:srgbClr val="C6D3DC"/>
+                </a:solidFill>
+              </a:rPr>
+              <a:t>docker exec zap curl http://dvwa/ answers 2xx or 3xx. A real app can be any dev or test URL ZAP can reach.</a:t>
+            </a:r>
           </a:p>
         </p:txBody>
       </p:sp>
@@ -14346,6 +14700,1710 @@
             <a:fld id="{F7021451-1387-4CA6-816F-3879F97B5CBC}" type="slidenum">
               <a:rPr b="0" lang="en-US"/>
               <a:t>3</a:t>
+            </a:fld>
+            <a:endParaRPr lang="en-US"/>
+          </a:p>
+        </p:txBody>
+      </p:sp>
+    </p:spTree>
+  </p:cSld>
+  <p:clrMapOvr>
+    <a:masterClrMapping/>
+  </p:clrMapOvr>
+</p:sld>
+</file>
+
+<file path=ppt/slides/slide30.xml><?xml version="1.0" encoding="utf-8"?>
+<p:sld xmlns:a="http://schemas.openxmlformats.org/drawingml/2006/main" xmlns:r="http://schemas.openxmlformats.org/officeDocument/2006/relationships" xmlns:p="http://schemas.openxmlformats.org/presentationml/2006/main">
+  <p:cSld name="0 · Prepare, then start the stack">
+    <p:spTree>
+      <p:nvGrpSpPr>
+        <p:cNvPr id="1" name=""/>
+        <p:cNvGrpSpPr/>
+        <p:nvPr/>
+      </p:nvGrpSpPr>
+      <p:grpSpPr>
+        <a:xfrm>
+          <a:off x="0" y="0"/>
+          <a:ext cx="0" cy="0"/>
+          <a:chOff x="0" y="0"/>
+          <a:chExt cx="0" cy="0"/>
+        </a:xfrm>
+      </p:grpSpPr>
+      <p:sp>
+        <p:nvSpPr>
+          <p:cNvPr id="2" name="Text 0"/>
+          <p:cNvSpPr/>
+          <p:nvPr>
+            <p:ph idx="100" type="title" hasCustomPrompt="1"/>
+          </p:nvPr>
+        </p:nvSpPr>
+        <p:spPr>
+          <a:xfrm>
+            <a:off x="548640" y="320040"/>
+            <a:ext cx="11064240" cy="777240"/>
+          </a:xfrm>
+          <a:prstGeom prst="rect">
+            <a:avLst/>
+          </a:prstGeom>
+          <a:noFill/>
+          <a:ln/>
+        </p:spPr>
+        <p:txBody>
+          <a:bodyPr wrap="square" lIns="0" tIns="0" rIns="0" bIns="0" rtlCol="0" anchor="ctr"/>
+          <a:lstStyle/>
+          <a:p>
+            <a:pPr algn="l" indent="0" marL="0">
+              <a:buNone/>
+            </a:pPr>
+            <a:r>
+              <a:rPr lang="en-US" sz="3000" b="1" dirty="0">
+                <a:solidFill>
+                  <a:schemeClr val="tx1"/>
+                </a:solidFill>
+              </a:rPr>
+              <a:t>0 · Prepare, then start the stack</a:t>
+            </a:r>
+            <a:endParaRPr lang="en-US" sz="3000" dirty="0"/>
+          </a:p>
+        </p:txBody>
+      </p:sp>
+      <p:sp>
+        <p:nvSpPr>
+          <p:cNvPr id="3" name="Non-production only card"/>
+          <p:cNvSpPr/>
+          <p:nvPr/>
+        </p:nvSpPr>
+        <p:spPr>
+          <a:xfrm>
+            <a:off x="548640" y="1371600"/>
+            <a:ext cx="3566160" cy="2148840"/>
+          </a:xfrm>
+          <a:prstGeom prst="roundRect">
+            <a:avLst>
+              <a:gd name="adj" fmla="val 5106"/>
+            </a:avLst>
+          </a:prstGeom>
+          <a:solidFill>
+            <a:schemeClr val="bg2"/>
+          </a:solidFill>
+          <a:ln w="12700">
+            <a:solidFill>
+              <a:schemeClr val="bg2"/>
+            </a:solidFill>
+            <a:prstDash val="solid"/>
+          </a:ln>
+        </p:spPr>
+      </p:sp>
+      <p:sp>
+        <p:nvSpPr>
+          <p:cNvPr id="4" name="Non-production only rule"/>
+          <p:cNvSpPr/>
+          <p:nvPr/>
+        </p:nvSpPr>
+        <p:spPr>
+          <a:xfrm>
+            <a:off x="548640" y="1371600"/>
+            <a:ext cx="82296" cy="2148840"/>
+          </a:xfrm>
+          <a:prstGeom prst="rect">
+            <a:avLst/>
+          </a:prstGeom>
+          <a:solidFill>
+            <a:schemeClr val="accent1"/>
+          </a:solidFill>
+          <a:ln w="12700">
+            <a:solidFill>
+              <a:schemeClr val="accent1"/>
+            </a:solidFill>
+            <a:prstDash val="solid"/>
+          </a:ln>
+        </p:spPr>
+      </p:sp>
+      <p:sp>
+        <p:nvSpPr>
+          <p:cNvPr id="5" name="Text 3"/>
+          <p:cNvSpPr txBox="1"/>
+          <p:nvPr/>
+        </p:nvSpPr>
+        <p:spPr>
+          <a:xfrm>
+            <a:off x="868680" y="1645920"/>
+            <a:ext cx="3017520" cy="640080"/>
+          </a:xfrm>
+          <a:prstGeom prst="rect">
+            <a:avLst/>
+          </a:prstGeom>
+          <a:noFill/>
+          <a:ln/>
+        </p:spPr>
+        <p:txBody>
+          <a:bodyPr wrap="square" lIns="0" tIns="0" rIns="0" bIns="0" rtlCol="0" anchor="t"/>
+          <a:lstStyle/>
+          <a:p>
+            <a:pPr indent="0" marL="0">
+              <a:buNone/>
+            </a:pPr>
+            <a:r>
+              <a:rPr lang="en-US" sz="1700" b="1" dirty="0">
+                <a:solidFill>
+                  <a:schemeClr val="tx1"/>
+                </a:solidFill>
+              </a:rPr>
+              <a:t>Non-production only</a:t>
+            </a:r>
+            <a:endParaRPr lang="en-US" sz="1700" dirty="0"/>
+          </a:p>
+        </p:txBody>
+      </p:sp>
+      <p:sp>
+        <p:nvSpPr>
+          <p:cNvPr id="6" name="Text 4"/>
+          <p:cNvSpPr txBox="1"/>
+          <p:nvPr/>
+        </p:nvSpPr>
+        <p:spPr>
+          <a:xfrm>
+            <a:off x="868680" y="2331720"/>
+            <a:ext cx="3017520" cy="1051560"/>
+          </a:xfrm>
+          <a:prstGeom prst="rect">
+            <a:avLst/>
+          </a:prstGeom>
+          <a:noFill/>
+          <a:ln/>
+        </p:spPr>
+        <p:txBody>
+          <a:bodyPr wrap="square" lIns="0" tIns="0" rIns="0" bIns="0" rtlCol="0" anchor="t"/>
+          <a:lstStyle/>
+          <a:p>
+            <a:pPr indent="0" marL="0">
+              <a:buNone/>
+            </a:pPr>
+            <a:r>
+              <a:rPr lang="en-US" sz="1350" dirty="0">
+                <a:solidFill>
+                  <a:schemeClr val="tx2"/>
+                </a:solidFill>
+              </a:rPr>
+              <a:t>Production hosts are refused before any traffic, whatever the scope says. DVWA is dev.</a:t>
+            </a:r>
+            <a:endParaRPr lang="en-US" sz="1350" dirty="0"/>
+          </a:p>
+        </p:txBody>
+      </p:sp>
+      <p:sp>
+        <p:nvSpPr>
+          <p:cNvPr id="7" name="Shared hosts registered card"/>
+          <p:cNvSpPr/>
+          <p:nvPr/>
+        </p:nvSpPr>
+        <p:spPr>
+          <a:xfrm>
+            <a:off x="4297680" y="1371600"/>
+            <a:ext cx="3566160" cy="2148840"/>
+          </a:xfrm>
+          <a:prstGeom prst="roundRect">
+            <a:avLst>
+              <a:gd name="adj" fmla="val 5106"/>
+            </a:avLst>
+          </a:prstGeom>
+          <a:solidFill>
+            <a:schemeClr val="bg2"/>
+          </a:solidFill>
+          <a:ln w="12700">
+            <a:solidFill>
+              <a:schemeClr val="bg2"/>
+            </a:solidFill>
+            <a:prstDash val="solid"/>
+          </a:ln>
+        </p:spPr>
+      </p:sp>
+      <p:sp>
+        <p:nvSpPr>
+          <p:cNvPr id="8" name="Shared hosts registered rule"/>
+          <p:cNvSpPr/>
+          <p:nvPr/>
+        </p:nvSpPr>
+        <p:spPr>
+          <a:xfrm>
+            <a:off x="4297680" y="1371600"/>
+            <a:ext cx="82296" cy="2148840"/>
+          </a:xfrm>
+          <a:prstGeom prst="rect">
+            <a:avLst/>
+          </a:prstGeom>
+          <a:solidFill>
+            <a:schemeClr val="accent1"/>
+          </a:solidFill>
+          <a:ln w="12700">
+            <a:solidFill>
+              <a:schemeClr val="accent1"/>
+            </a:solidFill>
+            <a:prstDash val="solid"/>
+          </a:ln>
+        </p:spPr>
+      </p:sp>
+      <p:sp>
+        <p:nvSpPr>
+          <p:cNvPr id="9" name="Text 7"/>
+          <p:cNvSpPr txBox="1"/>
+          <p:nvPr/>
+        </p:nvSpPr>
+        <p:spPr>
+          <a:xfrm>
+            <a:off x="4617720" y="1645920"/>
+            <a:ext cx="3017520" cy="640080"/>
+          </a:xfrm>
+          <a:prstGeom prst="rect">
+            <a:avLst/>
+          </a:prstGeom>
+          <a:noFill/>
+          <a:ln/>
+        </p:spPr>
+        <p:txBody>
+          <a:bodyPr wrap="square" lIns="0" tIns="0" rIns="0" bIns="0" rtlCol="0" anchor="t"/>
+          <a:lstStyle/>
+          <a:p>
+            <a:pPr indent="0" marL="0">
+              <a:buNone/>
+            </a:pPr>
+            <a:r>
+              <a:rPr lang="en-US" sz="1700" b="1" dirty="0">
+                <a:solidFill>
+                  <a:schemeClr val="tx1"/>
+                </a:solidFill>
+              </a:rPr>
+              <a:t>Shared hosts registered</a:t>
+            </a:r>
+            <a:endParaRPr lang="en-US" sz="1700" dirty="0"/>
+          </a:p>
+        </p:txBody>
+      </p:sp>
+      <p:sp>
+        <p:nvSpPr>
+          <p:cNvPr id="10" name="Text 8"/>
+          <p:cNvSpPr txBox="1"/>
+          <p:nvPr/>
+        </p:nvSpPr>
+        <p:spPr>
+          <a:xfrm>
+            <a:off x="4617720" y="2331720"/>
+            <a:ext cx="3017520" cy="1051560"/>
+          </a:xfrm>
+          <a:prstGeom prst="rect">
+            <a:avLst/>
+          </a:prstGeom>
+          <a:noFill/>
+          <a:ln/>
+        </p:spPr>
+        <p:txBody>
+          <a:bodyPr wrap="square" lIns="0" tIns="0" rIns="0" bIns="0" rtlCol="0" anchor="t"/>
+          <a:lstStyle/>
+          <a:p>
+            <a:pPr indent="0" marL="0">
+              <a:buNone/>
+            </a:pPr>
+            <a:r>
+              <a:rPr lang="en-US" sz="1350" dirty="0">
+                <a:solidFill>
+                  <a:schemeClr val="tx2"/>
+                </a:solidFill>
+              </a:rPr>
+              <a:t>Test and staging hosts must be in security/dast/environments.yaml with their class. Dev hosts needn't be.</a:t>
+            </a:r>
+            <a:endParaRPr lang="en-US" sz="1350" dirty="0"/>
+          </a:p>
+        </p:txBody>
+      </p:sp>
+      <p:sp>
+        <p:nvSpPr>
+          <p:cNvPr id="11" name="A test account card"/>
+          <p:cNvSpPr/>
+          <p:nvPr/>
+        </p:nvSpPr>
+        <p:spPr>
+          <a:xfrm>
+            <a:off x="8046720" y="1371600"/>
+            <a:ext cx="3566160" cy="2148840"/>
+          </a:xfrm>
+          <a:prstGeom prst="roundRect">
+            <a:avLst>
+              <a:gd name="adj" fmla="val 5106"/>
+            </a:avLst>
+          </a:prstGeom>
+          <a:solidFill>
+            <a:schemeClr val="bg2"/>
+          </a:solidFill>
+          <a:ln w="12700">
+            <a:solidFill>
+              <a:schemeClr val="bg2"/>
+            </a:solidFill>
+            <a:prstDash val="solid"/>
+          </a:ln>
+        </p:spPr>
+      </p:sp>
+      <p:sp>
+        <p:nvSpPr>
+          <p:cNvPr id="12" name="A test account rule"/>
+          <p:cNvSpPr/>
+          <p:nvPr/>
+        </p:nvSpPr>
+        <p:spPr>
+          <a:xfrm>
+            <a:off x="8046720" y="1371600"/>
+            <a:ext cx="82296" cy="2148840"/>
+          </a:xfrm>
+          <a:prstGeom prst="rect">
+            <a:avLst/>
+          </a:prstGeom>
+          <a:solidFill>
+            <a:schemeClr val="accent1"/>
+          </a:solidFill>
+          <a:ln w="12700">
+            <a:solidFill>
+              <a:schemeClr val="accent1"/>
+            </a:solidFill>
+            <a:prstDash val="solid"/>
+          </a:ln>
+        </p:spPr>
+      </p:sp>
+      <p:sp>
+        <p:nvSpPr>
+          <p:cNvPr id="13" name="Text 11"/>
+          <p:cNvSpPr txBox="1"/>
+          <p:nvPr/>
+        </p:nvSpPr>
+        <p:spPr>
+          <a:xfrm>
+            <a:off x="8366760" y="1645920"/>
+            <a:ext cx="3017520" cy="640080"/>
+          </a:xfrm>
+          <a:prstGeom prst="rect">
+            <a:avLst/>
+          </a:prstGeom>
+          <a:noFill/>
+          <a:ln/>
+        </p:spPr>
+        <p:txBody>
+          <a:bodyPr wrap="square" lIns="0" tIns="0" rIns="0" bIns="0" rtlCol="0" anchor="t"/>
+          <a:lstStyle/>
+          <a:p>
+            <a:pPr indent="0" marL="0">
+              <a:buNone/>
+            </a:pPr>
+            <a:r>
+              <a:rPr lang="en-US" sz="1700" b="1" dirty="0">
+                <a:solidFill>
+                  <a:schemeClr val="tx1"/>
+                </a:solidFill>
+              </a:rPr>
+              <a:t>A test account</a:t>
+            </a:r>
+            <a:endParaRPr lang="en-US" sz="1700" dirty="0"/>
+          </a:p>
+        </p:txBody>
+      </p:sp>
+      <p:sp>
+        <p:nvSpPr>
+          <p:cNvPr id="14" name="Text 12"/>
+          <p:cNvSpPr txBox="1"/>
+          <p:nvPr/>
+        </p:nvSpPr>
+        <p:spPr>
+          <a:xfrm>
+            <a:off x="8366760" y="2331720"/>
+            <a:ext cx="3017520" cy="1051560"/>
+          </a:xfrm>
+          <a:prstGeom prst="rect">
+            <a:avLst/>
+          </a:prstGeom>
+          <a:noFill/>
+          <a:ln/>
+        </p:spPr>
+        <p:txBody>
+          <a:bodyPr wrap="square" lIns="0" tIns="0" rIns="0" bIns="0" rtlCol="0" anchor="t"/>
+          <a:lstStyle/>
+          <a:p>
+            <a:pPr indent="0" marL="0">
+              <a:buNone/>
+            </a:pPr>
+            <a:r>
+              <a:rPr lang="en-US" sz="1350" dirty="0">
+                <a:solidFill>
+                  <a:schemeClr val="tx2"/>
+                </a:solidFill>
+              </a:rPr>
+              <a:t>The tool never creates accounts unless the app allows it. DVWA's admin; log in once by hand to check it.</a:t>
+            </a:r>
+            <a:endParaRPr lang="en-US" sz="1350" dirty="0"/>
+          </a:p>
+        </p:txBody>
+      </p:sp>
+      <p:sp>
+        <p:nvSpPr>
+          <p:cNvPr id="15" name="One-time app prep card"/>
+          <p:cNvSpPr/>
+          <p:nvPr/>
+        </p:nvSpPr>
+        <p:spPr>
+          <a:xfrm>
+            <a:off x="548640" y="3749040"/>
+            <a:ext cx="3566160" cy="2148840"/>
+          </a:xfrm>
+          <a:prstGeom prst="roundRect">
+            <a:avLst>
+              <a:gd name="adj" fmla="val 5106"/>
+            </a:avLst>
+          </a:prstGeom>
+          <a:solidFill>
+            <a:schemeClr val="bg2"/>
+          </a:solidFill>
+          <a:ln w="12700">
+            <a:solidFill>
+              <a:schemeClr val="bg2"/>
+            </a:solidFill>
+            <a:prstDash val="solid"/>
+          </a:ln>
+        </p:spPr>
+      </p:sp>
+      <p:sp>
+        <p:nvSpPr>
+          <p:cNvPr id="16" name="One-time app prep rule"/>
+          <p:cNvSpPr/>
+          <p:nvPr/>
+        </p:nvSpPr>
+        <p:spPr>
+          <a:xfrm>
+            <a:off x="548640" y="3749040"/>
+            <a:ext cx="82296" cy="2148840"/>
+          </a:xfrm>
+          <a:prstGeom prst="rect">
+            <a:avLst/>
+          </a:prstGeom>
+          <a:solidFill>
+            <a:schemeClr val="accent1"/>
+          </a:solidFill>
+          <a:ln w="12700">
+            <a:solidFill>
+              <a:schemeClr val="accent1"/>
+            </a:solidFill>
+            <a:prstDash val="solid"/>
+          </a:ln>
+        </p:spPr>
+      </p:sp>
+      <p:sp>
+        <p:nvSpPr>
+          <p:cNvPr id="17" name="Text 15"/>
+          <p:cNvSpPr txBox="1"/>
+          <p:nvPr/>
+        </p:nvSpPr>
+        <p:spPr>
+          <a:xfrm>
+            <a:off x="868680" y="4023360"/>
+            <a:ext cx="3017520" cy="640080"/>
+          </a:xfrm>
+          <a:prstGeom prst="rect">
+            <a:avLst/>
+          </a:prstGeom>
+          <a:noFill/>
+          <a:ln/>
+        </p:spPr>
+        <p:txBody>
+          <a:bodyPr wrap="square" lIns="0" tIns="0" rIns="0" bIns="0" rtlCol="0" anchor="t"/>
+          <a:lstStyle/>
+          <a:p>
+            <a:pPr indent="0" marL="0">
+              <a:buNone/>
+            </a:pPr>
+            <a:r>
+              <a:rPr lang="en-US" sz="1700" b="1" dirty="0">
+                <a:solidFill>
+                  <a:schemeClr val="tx1"/>
+                </a:solidFill>
+              </a:rPr>
+              <a:t>One-time app prep</a:t>
+            </a:r>
+            <a:endParaRPr lang="en-US" sz="1700" dirty="0"/>
+          </a:p>
+        </p:txBody>
+      </p:sp>
+      <p:sp>
+        <p:nvSpPr>
+          <p:cNvPr id="18" name="Text 16"/>
+          <p:cNvSpPr txBox="1"/>
+          <p:nvPr/>
+        </p:nvSpPr>
+        <p:spPr>
+          <a:xfrm>
+            <a:off x="868680" y="4709160"/>
+            <a:ext cx="3017520" cy="1051560"/>
+          </a:xfrm>
+          <a:prstGeom prst="rect">
+            <a:avLst/>
+          </a:prstGeom>
+          <a:noFill/>
+          <a:ln/>
+        </p:spPr>
+        <p:txBody>
+          <a:bodyPr wrap="square" lIns="0" tIns="0" rIns="0" bIns="0" rtlCol="0" anchor="t"/>
+          <a:lstStyle/>
+          <a:p>
+            <a:pPr indent="0" marL="0">
+              <a:buNone/>
+            </a:pPr>
+            <a:r>
+              <a:rPr lang="en-US" sz="1350" dirty="0">
+                <a:solidFill>
+                  <a:schemeClr val="tx2"/>
+                </a:solidFill>
+              </a:rPr>
+              <a:t>What a person does by hand the first time. DVWA: /setup.php → Create / Reset Database.</a:t>
+            </a:r>
+            <a:endParaRPr lang="en-US" sz="1350" dirty="0"/>
+          </a:p>
+        </p:txBody>
+      </p:sp>
+      <p:sp>
+        <p:nvSpPr>
+          <p:cNvPr id="19" name="Secrets in the shell, by name card"/>
+          <p:cNvSpPr/>
+          <p:nvPr/>
+        </p:nvSpPr>
+        <p:spPr>
+          <a:xfrm>
+            <a:off x="4297680" y="3749040"/>
+            <a:ext cx="3566160" cy="2148840"/>
+          </a:xfrm>
+          <a:prstGeom prst="roundRect">
+            <a:avLst>
+              <a:gd name="adj" fmla="val 5106"/>
+            </a:avLst>
+          </a:prstGeom>
+          <a:solidFill>
+            <a:schemeClr val="bg2"/>
+          </a:solidFill>
+          <a:ln w="12700">
+            <a:solidFill>
+              <a:schemeClr val="bg2"/>
+            </a:solidFill>
+            <a:prstDash val="solid"/>
+          </a:ln>
+        </p:spPr>
+      </p:sp>
+      <p:sp>
+        <p:nvSpPr>
+          <p:cNvPr id="20" name="Secrets in the shell, by name rule"/>
+          <p:cNvSpPr/>
+          <p:nvPr/>
+        </p:nvSpPr>
+        <p:spPr>
+          <a:xfrm>
+            <a:off x="4297680" y="3749040"/>
+            <a:ext cx="82296" cy="2148840"/>
+          </a:xfrm>
+          <a:prstGeom prst="rect">
+            <a:avLst/>
+          </a:prstGeom>
+          <a:solidFill>
+            <a:schemeClr val="accent1"/>
+          </a:solidFill>
+          <a:ln w="12700">
+            <a:solidFill>
+              <a:schemeClr val="accent1"/>
+            </a:solidFill>
+            <a:prstDash val="solid"/>
+          </a:ln>
+        </p:spPr>
+      </p:sp>
+      <p:sp>
+        <p:nvSpPr>
+          <p:cNvPr id="21" name="Text 19"/>
+          <p:cNvSpPr txBox="1"/>
+          <p:nvPr/>
+        </p:nvSpPr>
+        <p:spPr>
+          <a:xfrm>
+            <a:off x="4617720" y="4023360"/>
+            <a:ext cx="3017520" cy="640080"/>
+          </a:xfrm>
+          <a:prstGeom prst="rect">
+            <a:avLst/>
+          </a:prstGeom>
+          <a:noFill/>
+          <a:ln/>
+        </p:spPr>
+        <p:txBody>
+          <a:bodyPr wrap="square" lIns="0" tIns="0" rIns="0" bIns="0" rtlCol="0" anchor="t"/>
+          <a:lstStyle/>
+          <a:p>
+            <a:pPr indent="0" marL="0">
+              <a:buNone/>
+            </a:pPr>
+            <a:r>
+              <a:rPr lang="en-US" sz="1700" b="1" dirty="0">
+                <a:solidFill>
+                  <a:schemeClr val="tx1"/>
+                </a:solidFill>
+              </a:rPr>
+              <a:t>Secrets in the shell, by name</a:t>
+            </a:r>
+            <a:endParaRPr lang="en-US" sz="1700" dirty="0"/>
+          </a:p>
+        </p:txBody>
+      </p:sp>
+      <p:sp>
+        <p:nvSpPr>
+          <p:cNvPr id="22" name="Text 20"/>
+          <p:cNvSpPr txBox="1"/>
+          <p:nvPr/>
+        </p:nvSpPr>
+        <p:spPr>
+          <a:xfrm>
+            <a:off x="4617720" y="4709160"/>
+            <a:ext cx="3017520" cy="1051560"/>
+          </a:xfrm>
+          <a:prstGeom prst="rect">
+            <a:avLst/>
+          </a:prstGeom>
+          <a:noFill/>
+          <a:ln/>
+        </p:spPr>
+        <p:txBody>
+          <a:bodyPr wrap="square" lIns="0" tIns="0" rIns="0" bIns="0" rtlCol="0" anchor="t"/>
+          <a:lstStyle/>
+          <a:p>
+            <a:pPr indent="0" marL="0">
+              <a:buNone/>
+            </a:pPr>
+            <a:r>
+              <a:rPr lang="en-US" sz="1350" dirty="0">
+                <a:solidFill>
+                  <a:schemeClr val="tx2"/>
+                </a:solidFill>
+              </a:rPr>
+              <a:t>DVWA_USER, DVWA_PASS, ZAP_API_KEY (the key ZAP started with); ANTHROPIC_API_KEY for discovery, optional.</a:t>
+            </a:r>
+            <a:endParaRPr lang="en-US" sz="1350" dirty="0"/>
+          </a:p>
+        </p:txBody>
+      </p:sp>
+      <p:sp>
+        <p:nvSpPr>
+          <p:cNvPr id="23" name="Start ZAP, the app and the UI card"/>
+          <p:cNvSpPr/>
+          <p:nvPr/>
+        </p:nvSpPr>
+        <p:spPr>
+          <a:xfrm>
+            <a:off x="8046720" y="3749040"/>
+            <a:ext cx="3566160" cy="2148840"/>
+          </a:xfrm>
+          <a:prstGeom prst="roundRect">
+            <a:avLst>
+              <a:gd name="adj" fmla="val 5106"/>
+            </a:avLst>
+          </a:prstGeom>
+          <a:solidFill>
+            <a:schemeClr val="bg2"/>
+          </a:solidFill>
+          <a:ln w="12700">
+            <a:solidFill>
+              <a:schemeClr val="bg2"/>
+            </a:solidFill>
+            <a:prstDash val="solid"/>
+          </a:ln>
+        </p:spPr>
+      </p:sp>
+      <p:sp>
+        <p:nvSpPr>
+          <p:cNvPr id="24" name="Start ZAP, the app and the UI rule"/>
+          <p:cNvSpPr/>
+          <p:nvPr/>
+        </p:nvSpPr>
+        <p:spPr>
+          <a:xfrm>
+            <a:off x="8046720" y="3749040"/>
+            <a:ext cx="82296" cy="2148840"/>
+          </a:xfrm>
+          <a:prstGeom prst="rect">
+            <a:avLst/>
+          </a:prstGeom>
+          <a:solidFill>
+            <a:schemeClr val="accent1"/>
+          </a:solidFill>
+          <a:ln w="12700">
+            <a:solidFill>
+              <a:schemeClr val="accent1"/>
+            </a:solidFill>
+            <a:prstDash val="solid"/>
+          </a:ln>
+        </p:spPr>
+      </p:sp>
+      <p:sp>
+        <p:nvSpPr>
+          <p:cNvPr id="25" name="Text 23"/>
+          <p:cNvSpPr txBox="1"/>
+          <p:nvPr/>
+        </p:nvSpPr>
+        <p:spPr>
+          <a:xfrm>
+            <a:off x="8366760" y="4023360"/>
+            <a:ext cx="3017520" cy="640080"/>
+          </a:xfrm>
+          <a:prstGeom prst="rect">
+            <a:avLst/>
+          </a:prstGeom>
+          <a:noFill/>
+          <a:ln/>
+        </p:spPr>
+        <p:txBody>
+          <a:bodyPr wrap="square" lIns="0" tIns="0" rIns="0" bIns="0" rtlCol="0" anchor="t"/>
+          <a:lstStyle/>
+          <a:p>
+            <a:pPr indent="0" marL="0">
+              <a:buNone/>
+            </a:pPr>
+            <a:r>
+              <a:rPr lang="en-US" sz="1700" b="1" dirty="0">
+                <a:solidFill>
+                  <a:schemeClr val="tx1"/>
+                </a:solidFill>
+              </a:rPr>
+              <a:t>Start ZAP, the app and the UI</a:t>
+            </a:r>
+            <a:endParaRPr lang="en-US" sz="1700" dirty="0"/>
+          </a:p>
+        </p:txBody>
+      </p:sp>
+      <p:sp>
+        <p:nvSpPr>
+          <p:cNvPr id="26" name="Text 24"/>
+          <p:cNvSpPr txBox="1"/>
+          <p:nvPr/>
+        </p:nvSpPr>
+        <p:spPr>
+          <a:xfrm>
+            <a:off x="8366760" y="4709160"/>
+            <a:ext cx="3017520" cy="1051560"/>
+          </a:xfrm>
+          <a:prstGeom prst="rect">
+            <a:avLst/>
+          </a:prstGeom>
+          <a:noFill/>
+          <a:ln/>
+        </p:spPr>
+        <p:txBody>
+          <a:bodyPr wrap="square" lIns="0" tIns="0" rIns="0" bIns="0" rtlCol="0" anchor="t"/>
+          <a:lstStyle/>
+          <a:p>
+            <a:pPr indent="0" marL="0">
+              <a:buNone/>
+            </a:pPr>
+            <a:r>
+              <a:rPr lang="en-US" sz="1350" dirty="0">
+                <a:solidFill>
+                  <a:schemeClr val="tx2"/>
+                </a:solidFill>
+              </a:rPr>
+              <a:t>docker compose --profile dvwa up -d dvwa zap, then python -m dast ui and open its one-time link.</a:t>
+            </a:r>
+            <a:endParaRPr lang="en-US" sz="1350" dirty="0"/>
+          </a:p>
+        </p:txBody>
+      </p:sp>
+      <p:sp>
+        <p:nvSpPr>
+          <p:cNvPr id="25" name="Slide Number Placeholder 0"/>
+          <p:cNvSpPr>
+            <a:spLocks noGrp="1"/>
+          </p:cNvSpPr>
+          <p:nvPr>
+            <p:ph type="sldNum" sz="quarter" idx="4294967295"/>
+          </p:nvPr>
+        </p:nvSpPr>
+        <p:spPr>
+          <a:xfrm>
+            <a:off x="11155680" y="6355080"/>
+            <a:ext cx="548640" cy="274320"/>
+          </a:xfrm>
+          <a:prstGeom prst="rect">
+            <a:avLst/>
+          </a:prstGeom>
+          <a:extLst>
+            <a:ext uri="{C572A759-6A51-4108-AA02-DFA0A04FC94B}">
+              <ma14:wrappingTextBoxFlag xmlns:ma14="http://schemas.microsoft.com/office/mac/drawingml/2011/main" val="0"/>
+            </a:ext>
+          </a:extLst>
+        </p:spPr>
+        <p:txBody>
+          <a:bodyPr/>
+          <a:lstStyle>
+            <a:lvl1pPr>
+              <a:defRPr sz="1000">
+                <a:solidFill>
+                  <a:srgbClr val="6B7480"/>
+                </a:solidFill>
+              </a:defRPr>
+            </a:lvl1pPr>
+          </a:lstStyle>
+          <a:p>
+            <a:pPr algn="r"/>
+            <a:fld id="{F7021451-1387-4CA6-816F-3879F97B5CBC}" type="slidenum">
+              <a:rPr b="0" lang="en-US"/>
+              <a:t>25</a:t>
+            </a:fld>
+            <a:endParaRPr lang="en-US"/>
+          </a:p>
+        </p:txBody>
+      </p:sp>
+    </p:spTree>
+  </p:cSld>
+  <p:clrMapOvr>
+    <a:masterClrMapping/>
+  </p:clrMapOvr>
+</p:sld>
+</file>
+
+<file path=ppt/slides/slide31.xml><?xml version="1.0" encoding="utf-8"?>
+<p:sld xmlns:a="http://schemas.openxmlformats.org/drawingml/2006/main" xmlns:r="http://schemas.openxmlformats.org/officeDocument/2006/relationships" xmlns:p="http://schemas.openxmlformats.org/presentationml/2006/main">
+  <p:cSld name="The same run without the UI">
+    <p:spTree>
+      <p:nvGrpSpPr>
+        <p:cNvPr id="1" name=""/>
+        <p:cNvGrpSpPr/>
+        <p:nvPr/>
+      </p:nvGrpSpPr>
+      <p:grpSpPr>
+        <a:xfrm>
+          <a:off x="0" y="0"/>
+          <a:ext cx="0" cy="0"/>
+          <a:chOff x="0" y="0"/>
+          <a:chExt cx="0" cy="0"/>
+        </a:xfrm>
+      </p:grpSpPr>
+      <p:sp>
+        <p:nvSpPr>
+          <p:cNvPr id="2" name="Text 0"/>
+          <p:cNvSpPr/>
+          <p:nvPr>
+            <p:ph idx="100" type="title" hasCustomPrompt="1"/>
+          </p:nvPr>
+        </p:nvSpPr>
+        <p:spPr>
+          <a:xfrm>
+            <a:off x="548640" y="320040"/>
+            <a:ext cx="11064240" cy="777240"/>
+          </a:xfrm>
+          <a:prstGeom prst="rect">
+            <a:avLst/>
+          </a:prstGeom>
+          <a:noFill/>
+          <a:ln/>
+        </p:spPr>
+        <p:txBody>
+          <a:bodyPr wrap="square" lIns="0" tIns="0" rIns="0" bIns="0" rtlCol="0" anchor="ctr"/>
+          <a:lstStyle/>
+          <a:p>
+            <a:pPr algn="l" indent="0" marL="0">
+              <a:buNone/>
+            </a:pPr>
+            <a:r>
+              <a:rPr lang="en-US" sz="3200" b="1" dirty="0">
+                <a:solidFill>
+                  <a:schemeClr val="tx1"/>
+                </a:solidFill>
+              </a:rPr>
+              <a:t>The same run without the UI</a:t>
+            </a:r>
+            <a:endParaRPr lang="en-US" sz="3200" dirty="0"/>
+          </a:p>
+        </p:txBody>
+      </p:sp>
+      <p:sp>
+        <p:nvSpPr>
+          <p:cNvPr id="3" name="1 · Onboard card"/>
+          <p:cNvSpPr/>
+          <p:nvPr/>
+        </p:nvSpPr>
+        <p:spPr>
+          <a:xfrm>
+            <a:off x="548640" y="1371600"/>
+            <a:ext cx="3566160" cy="2148840"/>
+          </a:xfrm>
+          <a:prstGeom prst="roundRect">
+            <a:avLst>
+              <a:gd name="adj" fmla="val 5106"/>
+            </a:avLst>
+          </a:prstGeom>
+          <a:solidFill>
+            <a:schemeClr val="bg2"/>
+          </a:solidFill>
+          <a:ln w="12700">
+            <a:solidFill>
+              <a:schemeClr val="bg2"/>
+            </a:solidFill>
+            <a:prstDash val="solid"/>
+          </a:ln>
+        </p:spPr>
+      </p:sp>
+      <p:sp>
+        <p:nvSpPr>
+          <p:cNvPr id="4" name="1 · Onboard rule"/>
+          <p:cNvSpPr/>
+          <p:nvPr/>
+        </p:nvSpPr>
+        <p:spPr>
+          <a:xfrm>
+            <a:off x="548640" y="1371600"/>
+            <a:ext cx="82296" cy="2148840"/>
+          </a:xfrm>
+          <a:prstGeom prst="rect">
+            <a:avLst/>
+          </a:prstGeom>
+          <a:solidFill>
+            <a:schemeClr val="accent1"/>
+          </a:solidFill>
+          <a:ln w="12700">
+            <a:solidFill>
+              <a:schemeClr val="accent1"/>
+            </a:solidFill>
+            <a:prstDash val="solid"/>
+          </a:ln>
+        </p:spPr>
+      </p:sp>
+      <p:sp>
+        <p:nvSpPr>
+          <p:cNvPr id="5" name="Text 3"/>
+          <p:cNvSpPr txBox="1"/>
+          <p:nvPr/>
+        </p:nvSpPr>
+        <p:spPr>
+          <a:xfrm>
+            <a:off x="868680" y="1645920"/>
+            <a:ext cx="3017520" cy="640080"/>
+          </a:xfrm>
+          <a:prstGeom prst="rect">
+            <a:avLst/>
+          </a:prstGeom>
+          <a:noFill/>
+          <a:ln/>
+        </p:spPr>
+        <p:txBody>
+          <a:bodyPr wrap="square" lIns="0" tIns="0" rIns="0" bIns="0" rtlCol="0" anchor="t"/>
+          <a:lstStyle/>
+          <a:p>
+            <a:pPr indent="0" marL="0">
+              <a:buNone/>
+            </a:pPr>
+            <a:r>
+              <a:rPr lang="en-US" sz="1700" b="1" dirty="0">
+                <a:solidFill>
+                  <a:schemeClr val="tx1"/>
+                </a:solidFill>
+              </a:rPr>
+              <a:t>1 · Onboard</a:t>
+            </a:r>
+            <a:endParaRPr lang="en-US" sz="1700" dirty="0"/>
+          </a:p>
+        </p:txBody>
+      </p:sp>
+      <p:sp>
+        <p:nvSpPr>
+          <p:cNvPr id="6" name="Text 4"/>
+          <p:cNvSpPr txBox="1"/>
+          <p:nvPr/>
+        </p:nvSpPr>
+        <p:spPr>
+          <a:xfrm>
+            <a:off x="868680" y="2331720"/>
+            <a:ext cx="3017520" cy="1051560"/>
+          </a:xfrm>
+          <a:prstGeom prst="rect">
+            <a:avLst/>
+          </a:prstGeom>
+          <a:noFill/>
+          <a:ln/>
+        </p:spPr>
+        <p:txBody>
+          <a:bodyPr wrap="square" lIns="0" tIns="0" rIns="0" bIns="0" rtlCol="0" anchor="t"/>
+          <a:lstStyle/>
+          <a:p>
+            <a:pPr indent="0" marL="0">
+              <a:buNone/>
+            </a:pPr>
+            <a:r>
+              <a:rPr lang="en-US" sz="1350" dirty="0">
+                <a:solidFill>
+                  <a:schemeClr val="tx2"/>
+                </a:solidFill>
+              </a:rPr>
+              <a:t>dast onboard dvwa ‑‑discover, given the address (http://dvwa), the login page and ZAP as proxy. Writes app.yaml.</a:t>
+            </a:r>
+            <a:endParaRPr lang="en-US" sz="1350" dirty="0"/>
+          </a:p>
+        </p:txBody>
+      </p:sp>
+      <p:sp>
+        <p:nvSpPr>
+          <p:cNvPr id="7" name="2 · Record the login card"/>
+          <p:cNvSpPr/>
+          <p:nvPr/>
+        </p:nvSpPr>
+        <p:spPr>
+          <a:xfrm>
+            <a:off x="4297680" y="1371600"/>
+            <a:ext cx="3566160" cy="2148840"/>
+          </a:xfrm>
+          <a:prstGeom prst="roundRect">
+            <a:avLst>
+              <a:gd name="adj" fmla="val 5106"/>
+            </a:avLst>
+          </a:prstGeom>
+          <a:solidFill>
+            <a:schemeClr val="bg2"/>
+          </a:solidFill>
+          <a:ln w="12700">
+            <a:solidFill>
+              <a:schemeClr val="bg2"/>
+            </a:solidFill>
+            <a:prstDash val="solid"/>
+          </a:ln>
+        </p:spPr>
+      </p:sp>
+      <p:sp>
+        <p:nvSpPr>
+          <p:cNvPr id="8" name="2 · Record the login rule"/>
+          <p:cNvSpPr/>
+          <p:nvPr/>
+        </p:nvSpPr>
+        <p:spPr>
+          <a:xfrm>
+            <a:off x="4297680" y="1371600"/>
+            <a:ext cx="82296" cy="2148840"/>
+          </a:xfrm>
+          <a:prstGeom prst="rect">
+            <a:avLst/>
+          </a:prstGeom>
+          <a:solidFill>
+            <a:schemeClr val="accent1"/>
+          </a:solidFill>
+          <a:ln w="12700">
+            <a:solidFill>
+              <a:schemeClr val="accent1"/>
+            </a:solidFill>
+            <a:prstDash val="solid"/>
+          </a:ln>
+        </p:spPr>
+      </p:sp>
+      <p:sp>
+        <p:nvSpPr>
+          <p:cNvPr id="9" name="Text 7"/>
+          <p:cNvSpPr txBox="1"/>
+          <p:nvPr/>
+        </p:nvSpPr>
+        <p:spPr>
+          <a:xfrm>
+            <a:off x="4617720" y="1645920"/>
+            <a:ext cx="3017520" cy="640080"/>
+          </a:xfrm>
+          <a:prstGeom prst="rect">
+            <a:avLst/>
+          </a:prstGeom>
+          <a:noFill/>
+          <a:ln/>
+        </p:spPr>
+        <p:txBody>
+          <a:bodyPr wrap="square" lIns="0" tIns="0" rIns="0" bIns="0" rtlCol="0" anchor="t"/>
+          <a:lstStyle/>
+          <a:p>
+            <a:pPr indent="0" marL="0">
+              <a:buNone/>
+            </a:pPr>
+            <a:r>
+              <a:rPr lang="en-US" sz="1700" b="1" dirty="0">
+                <a:solidFill>
+                  <a:schemeClr val="tx1"/>
+                </a:solidFill>
+              </a:rPr>
+              <a:t>2 · Record the login</a:t>
+            </a:r>
+            <a:endParaRPr lang="en-US" sz="1700" dirty="0"/>
+          </a:p>
+        </p:txBody>
+      </p:sp>
+      <p:sp>
+        <p:nvSpPr>
+          <p:cNvPr id="10" name="Text 8"/>
+          <p:cNvSpPr txBox="1"/>
+          <p:nvPr/>
+        </p:nvSpPr>
+        <p:spPr>
+          <a:xfrm>
+            <a:off x="4617720" y="2331720"/>
+            <a:ext cx="3017520" cy="1051560"/>
+          </a:xfrm>
+          <a:prstGeom prst="rect">
+            <a:avLst/>
+          </a:prstGeom>
+          <a:noFill/>
+          <a:ln/>
+        </p:spPr>
+        <p:txBody>
+          <a:bodyPr wrap="square" lIns="0" tIns="0" rIns="0" bIns="0" rtlCol="0" anchor="t"/>
+          <a:lstStyle/>
+          <a:p>
+            <a:pPr indent="0" marL="0">
+              <a:buNone/>
+            </a:pPr>
+            <a:r>
+              <a:rPr lang="en-US" sz="1350" dirty="0">
+                <a:solidFill>
+                  <a:schemeClr val="tx2"/>
+                </a:solidFill>
+              </a:rPr>
+              <a:t>dast author dvwa signs in with the test account, saves the steps and replays them to check.</a:t>
+            </a:r>
+            <a:endParaRPr lang="en-US" sz="1350" dirty="0"/>
+          </a:p>
+        </p:txBody>
+      </p:sp>
+      <p:sp>
+        <p:nvSpPr>
+          <p:cNvPr id="11" name="3 · Scan card"/>
+          <p:cNvSpPr/>
+          <p:nvPr/>
+        </p:nvSpPr>
+        <p:spPr>
+          <a:xfrm>
+            <a:off x="8046720" y="1371600"/>
+            <a:ext cx="3566160" cy="2148840"/>
+          </a:xfrm>
+          <a:prstGeom prst="roundRect">
+            <a:avLst>
+              <a:gd name="adj" fmla="val 5106"/>
+            </a:avLst>
+          </a:prstGeom>
+          <a:solidFill>
+            <a:schemeClr val="bg2"/>
+          </a:solidFill>
+          <a:ln w="12700">
+            <a:solidFill>
+              <a:schemeClr val="bg2"/>
+            </a:solidFill>
+            <a:prstDash val="solid"/>
+          </a:ln>
+        </p:spPr>
+      </p:sp>
+      <p:sp>
+        <p:nvSpPr>
+          <p:cNvPr id="12" name="3 · Scan rule"/>
+          <p:cNvSpPr/>
+          <p:nvPr/>
+        </p:nvSpPr>
+        <p:spPr>
+          <a:xfrm>
+            <a:off x="8046720" y="1371600"/>
+            <a:ext cx="82296" cy="2148840"/>
+          </a:xfrm>
+          <a:prstGeom prst="rect">
+            <a:avLst/>
+          </a:prstGeom>
+          <a:solidFill>
+            <a:schemeClr val="accent1"/>
+          </a:solidFill>
+          <a:ln w="12700">
+            <a:solidFill>
+              <a:schemeClr val="accent1"/>
+            </a:solidFill>
+            <a:prstDash val="solid"/>
+          </a:ln>
+        </p:spPr>
+      </p:sp>
+      <p:sp>
+        <p:nvSpPr>
+          <p:cNvPr id="13" name="Text 11"/>
+          <p:cNvSpPr txBox="1"/>
+          <p:nvPr/>
+        </p:nvSpPr>
+        <p:spPr>
+          <a:xfrm>
+            <a:off x="8366760" y="1645920"/>
+            <a:ext cx="3017520" cy="640080"/>
+          </a:xfrm>
+          <a:prstGeom prst="rect">
+            <a:avLst/>
+          </a:prstGeom>
+          <a:noFill/>
+          <a:ln/>
+        </p:spPr>
+        <p:txBody>
+          <a:bodyPr wrap="square" lIns="0" tIns="0" rIns="0" bIns="0" rtlCol="0" anchor="t"/>
+          <a:lstStyle/>
+          <a:p>
+            <a:pPr indent="0" marL="0">
+              <a:buNone/>
+            </a:pPr>
+            <a:r>
+              <a:rPr lang="en-US" sz="1700" b="1" dirty="0">
+                <a:solidFill>
+                  <a:schemeClr val="tx1"/>
+                </a:solidFill>
+              </a:rPr>
+              <a:t>3 · Scan</a:t>
+            </a:r>
+            <a:endParaRPr lang="en-US" sz="1700" dirty="0"/>
+          </a:p>
+        </p:txBody>
+      </p:sp>
+      <p:sp>
+        <p:nvSpPr>
+          <p:cNvPr id="14" name="Text 12"/>
+          <p:cNvSpPr txBox="1"/>
+          <p:nvPr/>
+        </p:nvSpPr>
+        <p:spPr>
+          <a:xfrm>
+            <a:off x="8366760" y="2331720"/>
+            <a:ext cx="3017520" cy="1051560"/>
+          </a:xfrm>
+          <a:prstGeom prst="rect">
+            <a:avLst/>
+          </a:prstGeom>
+          <a:noFill/>
+          <a:ln/>
+        </p:spPr>
+        <p:txBody>
+          <a:bodyPr wrap="square" lIns="0" tIns="0" rIns="0" bIns="0" rtlCol="0" anchor="t"/>
+          <a:lstStyle/>
+          <a:p>
+            <a:pPr indent="0" marL="0">
+              <a:buNone/>
+            </a:pPr>
+            <a:r>
+              <a:rPr lang="en-US" sz="1350" dirty="0">
+                <a:solidFill>
+                  <a:schemeClr val="tx2"/>
+                </a:solidFill>
+              </a:rPr>
+              <a:t>dast scan dvwa: safety checks, sign in, spider and active scan, organise, coverage.</a:t>
+            </a:r>
+            <a:endParaRPr lang="en-US" sz="1350" dirty="0"/>
+          </a:p>
+        </p:txBody>
+      </p:sp>
+      <p:sp>
+        <p:nvSpPr>
+          <p:cNvPr id="15" name="4 · Tune card"/>
+          <p:cNvSpPr/>
+          <p:nvPr/>
+        </p:nvSpPr>
+        <p:spPr>
+          <a:xfrm>
+            <a:off x="548640" y="3749040"/>
+            <a:ext cx="3566160" cy="2148840"/>
+          </a:xfrm>
+          <a:prstGeom prst="roundRect">
+            <a:avLst>
+              <a:gd name="adj" fmla="val 5106"/>
+            </a:avLst>
+          </a:prstGeom>
+          <a:solidFill>
+            <a:schemeClr val="bg2"/>
+          </a:solidFill>
+          <a:ln w="12700">
+            <a:solidFill>
+              <a:schemeClr val="bg2"/>
+            </a:solidFill>
+            <a:prstDash val="solid"/>
+          </a:ln>
+        </p:spPr>
+      </p:sp>
+      <p:sp>
+        <p:nvSpPr>
+          <p:cNvPr id="16" name="4 · Tune rule"/>
+          <p:cNvSpPr/>
+          <p:nvPr/>
+        </p:nvSpPr>
+        <p:spPr>
+          <a:xfrm>
+            <a:off x="548640" y="3749040"/>
+            <a:ext cx="82296" cy="2148840"/>
+          </a:xfrm>
+          <a:prstGeom prst="rect">
+            <a:avLst/>
+          </a:prstGeom>
+          <a:solidFill>
+            <a:schemeClr val="accent1"/>
+          </a:solidFill>
+          <a:ln w="12700">
+            <a:solidFill>
+              <a:schemeClr val="accent1"/>
+            </a:solidFill>
+            <a:prstDash val="solid"/>
+          </a:ln>
+        </p:spPr>
+      </p:sp>
+      <p:sp>
+        <p:nvSpPr>
+          <p:cNvPr id="17" name="Text 15"/>
+          <p:cNvSpPr txBox="1"/>
+          <p:nvPr/>
+        </p:nvSpPr>
+        <p:spPr>
+          <a:xfrm>
+            <a:off x="868680" y="4023360"/>
+            <a:ext cx="3017520" cy="640080"/>
+          </a:xfrm>
+          <a:prstGeom prst="rect">
+            <a:avLst/>
+          </a:prstGeom>
+          <a:noFill/>
+          <a:ln/>
+        </p:spPr>
+        <p:txBody>
+          <a:bodyPr wrap="square" lIns="0" tIns="0" rIns="0" bIns="0" rtlCol="0" anchor="t"/>
+          <a:lstStyle/>
+          <a:p>
+            <a:pPr indent="0" marL="0">
+              <a:buNone/>
+            </a:pPr>
+            <a:r>
+              <a:rPr lang="en-US" sz="1700" b="1" dirty="0">
+                <a:solidFill>
+                  <a:schemeClr val="tx1"/>
+                </a:solidFill>
+              </a:rPr>
+              <a:t>4 · Tune</a:t>
+            </a:r>
+            <a:endParaRPr lang="en-US" sz="1700" dirty="0"/>
+          </a:p>
+        </p:txBody>
+      </p:sp>
+      <p:sp>
+        <p:nvSpPr>
+          <p:cNvPr id="18" name="Text 16"/>
+          <p:cNvSpPr txBox="1"/>
+          <p:nvPr/>
+        </p:nvSpPr>
+        <p:spPr>
+          <a:xfrm>
+            <a:off x="868680" y="4709160"/>
+            <a:ext cx="3017520" cy="1051560"/>
+          </a:xfrm>
+          <a:prstGeom prst="rect">
+            <a:avLst/>
+          </a:prstGeom>
+          <a:noFill/>
+          <a:ln/>
+        </p:spPr>
+        <p:txBody>
+          <a:bodyPr wrap="square" lIns="0" tIns="0" rIns="0" bIns="0" rtlCol="0" anchor="t"/>
+          <a:lstStyle/>
+          <a:p>
+            <a:pPr indent="0" marL="0">
+              <a:buNone/>
+            </a:pPr>
+            <a:r>
+              <a:rPr lang="en-US" sz="1350" dirty="0">
+                <a:solidFill>
+                  <a:schemeClr val="tx2"/>
+                </a:solidFill>
+              </a:rPr>
+              <a:t>Edit security/dast/dvwa/app.yaml: the cookie, and the pages with their inputs. Then scan again.</a:t>
+            </a:r>
+            <a:endParaRPr lang="en-US" sz="1350" dirty="0"/>
+          </a:p>
+        </p:txBody>
+      </p:sp>
+      <p:sp>
+        <p:nvSpPr>
+          <p:cNvPr id="19" name="5 · Report and publish card"/>
+          <p:cNvSpPr/>
+          <p:nvPr/>
+        </p:nvSpPr>
+        <p:spPr>
+          <a:xfrm>
+            <a:off x="4297680" y="3749040"/>
+            <a:ext cx="3566160" cy="2148840"/>
+          </a:xfrm>
+          <a:prstGeom prst="roundRect">
+            <a:avLst>
+              <a:gd name="adj" fmla="val 5106"/>
+            </a:avLst>
+          </a:prstGeom>
+          <a:solidFill>
+            <a:schemeClr val="bg2"/>
+          </a:solidFill>
+          <a:ln w="12700">
+            <a:solidFill>
+              <a:schemeClr val="bg2"/>
+            </a:solidFill>
+            <a:prstDash val="solid"/>
+          </a:ln>
+        </p:spPr>
+      </p:sp>
+      <p:sp>
+        <p:nvSpPr>
+          <p:cNvPr id="20" name="5 · Report and publish rule"/>
+          <p:cNvSpPr/>
+          <p:nvPr/>
+        </p:nvSpPr>
+        <p:spPr>
+          <a:xfrm>
+            <a:off x="4297680" y="3749040"/>
+            <a:ext cx="82296" cy="2148840"/>
+          </a:xfrm>
+          <a:prstGeom prst="rect">
+            <a:avLst/>
+          </a:prstGeom>
+          <a:solidFill>
+            <a:schemeClr val="accent1"/>
+          </a:solidFill>
+          <a:ln w="12700">
+            <a:solidFill>
+              <a:schemeClr val="accent1"/>
+            </a:solidFill>
+            <a:prstDash val="solid"/>
+          </a:ln>
+        </p:spPr>
+      </p:sp>
+      <p:sp>
+        <p:nvSpPr>
+          <p:cNvPr id="21" name="Text 19"/>
+          <p:cNvSpPr txBox="1"/>
+          <p:nvPr/>
+        </p:nvSpPr>
+        <p:spPr>
+          <a:xfrm>
+            <a:off x="4617720" y="4023360"/>
+            <a:ext cx="3017520" cy="640080"/>
+          </a:xfrm>
+          <a:prstGeom prst="rect">
+            <a:avLst/>
+          </a:prstGeom>
+          <a:noFill/>
+          <a:ln/>
+        </p:spPr>
+        <p:txBody>
+          <a:bodyPr wrap="square" lIns="0" tIns="0" rIns="0" bIns="0" rtlCol="0" anchor="t"/>
+          <a:lstStyle/>
+          <a:p>
+            <a:pPr indent="0" marL="0">
+              <a:buNone/>
+            </a:pPr>
+            <a:r>
+              <a:rPr lang="en-US" sz="1700" b="1" dirty="0">
+                <a:solidFill>
+                  <a:schemeClr val="tx1"/>
+                </a:solidFill>
+              </a:rPr>
+              <a:t>5 · Report and publish</a:t>
+            </a:r>
+            <a:endParaRPr lang="en-US" sz="1700" dirty="0"/>
+          </a:p>
+        </p:txBody>
+      </p:sp>
+      <p:sp>
+        <p:nvSpPr>
+          <p:cNvPr id="22" name="Text 20"/>
+          <p:cNvSpPr txBox="1"/>
+          <p:nvPr/>
+        </p:nvSpPr>
+        <p:spPr>
+          <a:xfrm>
+            <a:off x="4617720" y="4709160"/>
+            <a:ext cx="3017520" cy="1051560"/>
+          </a:xfrm>
+          <a:prstGeom prst="rect">
+            <a:avLst/>
+          </a:prstGeom>
+          <a:noFill/>
+          <a:ln/>
+        </p:spPr>
+        <p:txBody>
+          <a:bodyPr wrap="square" lIns="0" tIns="0" rIns="0" bIns="0" rtlCol="0" anchor="t"/>
+          <a:lstStyle/>
+          <a:p>
+            <a:pPr indent="0" marL="0">
+              <a:buNone/>
+            </a:pPr>
+            <a:r>
+              <a:rPr lang="en-US" sz="1350" dirty="0">
+                <a:solidFill>
+                  <a:schemeClr val="tx2"/>
+                </a:solidFill>
+              </a:rPr>
+              <a:t>dast report dvwa compares with the last run and writes SARIF and summary.md; with ‑‑upload it publishes.</a:t>
+            </a:r>
+            <a:endParaRPr lang="en-US" sz="1350" dirty="0"/>
+          </a:p>
+        </p:txBody>
+      </p:sp>
+      <p:sp>
+        <p:nvSpPr>
+          <p:cNvPr id="23" name="6 · Triage card"/>
+          <p:cNvSpPr/>
+          <p:nvPr/>
+        </p:nvSpPr>
+        <p:spPr>
+          <a:xfrm>
+            <a:off x="8046720" y="3749040"/>
+            <a:ext cx="3566160" cy="2148840"/>
+          </a:xfrm>
+          <a:prstGeom prst="roundRect">
+            <a:avLst>
+              <a:gd name="adj" fmla="val 5106"/>
+            </a:avLst>
+          </a:prstGeom>
+          <a:solidFill>
+            <a:schemeClr val="bg2"/>
+          </a:solidFill>
+          <a:ln w="12700">
+            <a:solidFill>
+              <a:schemeClr val="bg2"/>
+            </a:solidFill>
+            <a:prstDash val="solid"/>
+          </a:ln>
+        </p:spPr>
+      </p:sp>
+      <p:sp>
+        <p:nvSpPr>
+          <p:cNvPr id="24" name="6 · Triage rule"/>
+          <p:cNvSpPr/>
+          <p:nvPr/>
+        </p:nvSpPr>
+        <p:spPr>
+          <a:xfrm>
+            <a:off x="8046720" y="3749040"/>
+            <a:ext cx="82296" cy="2148840"/>
+          </a:xfrm>
+          <a:prstGeom prst="rect">
+            <a:avLst/>
+          </a:prstGeom>
+          <a:solidFill>
+            <a:schemeClr val="accent1"/>
+          </a:solidFill>
+          <a:ln w="12700">
+            <a:solidFill>
+              <a:schemeClr val="accent1"/>
+            </a:solidFill>
+            <a:prstDash val="solid"/>
+          </a:ln>
+        </p:spPr>
+      </p:sp>
+      <p:sp>
+        <p:nvSpPr>
+          <p:cNvPr id="25" name="Text 23"/>
+          <p:cNvSpPr txBox="1"/>
+          <p:nvPr/>
+        </p:nvSpPr>
+        <p:spPr>
+          <a:xfrm>
+            <a:off x="8366760" y="4023360"/>
+            <a:ext cx="3017520" cy="640080"/>
+          </a:xfrm>
+          <a:prstGeom prst="rect">
+            <a:avLst/>
+          </a:prstGeom>
+          <a:noFill/>
+          <a:ln/>
+        </p:spPr>
+        <p:txBody>
+          <a:bodyPr wrap="square" lIns="0" tIns="0" rIns="0" bIns="0" rtlCol="0" anchor="t"/>
+          <a:lstStyle/>
+          <a:p>
+            <a:pPr indent="0" marL="0">
+              <a:buNone/>
+            </a:pPr>
+            <a:r>
+              <a:rPr lang="en-US" sz="1700" b="1" dirty="0">
+                <a:solidFill>
+                  <a:schemeClr val="tx1"/>
+                </a:solidFill>
+              </a:rPr>
+              <a:t>6 · Triage</a:t>
+            </a:r>
+            <a:endParaRPr lang="en-US" sz="1700" dirty="0"/>
+          </a:p>
+        </p:txBody>
+      </p:sp>
+      <p:sp>
+        <p:nvSpPr>
+          <p:cNvPr id="26" name="Text 24"/>
+          <p:cNvSpPr txBox="1"/>
+          <p:nvPr/>
+        </p:nvSpPr>
+        <p:spPr>
+          <a:xfrm>
+            <a:off x="8366760" y="4709160"/>
+            <a:ext cx="3017520" cy="1051560"/>
+          </a:xfrm>
+          <a:prstGeom prst="rect">
+            <a:avLst/>
+          </a:prstGeom>
+          <a:noFill/>
+          <a:ln/>
+        </p:spPr>
+        <p:txBody>
+          <a:bodyPr wrap="square" lIns="0" tIns="0" rIns="0" bIns="0" rtlCol="0" anchor="t"/>
+          <a:lstStyle/>
+          <a:p>
+            <a:pPr indent="0" marL="0">
+              <a:buNone/>
+            </a:pPr>
+            <a:r>
+              <a:rPr lang="en-US" sz="1350" dirty="0">
+                <a:solidFill>
+                  <a:schemeClr val="tx2"/>
+                </a:solidFill>
+              </a:rPr>
+              <a:t>Proposals and approvals go in the app's suppressions.yaml, the file report already reads.</a:t>
+            </a:r>
+            <a:endParaRPr lang="en-US" sz="1350" dirty="0"/>
+          </a:p>
+        </p:txBody>
+      </p:sp>
+      <p:sp>
+        <p:nvSpPr>
+          <p:cNvPr id="25" name="Slide Number Placeholder 0"/>
+          <p:cNvSpPr>
+            <a:spLocks noGrp="1"/>
+          </p:cNvSpPr>
+          <p:nvPr>
+            <p:ph type="sldNum" sz="quarter" idx="4294967295"/>
+          </p:nvPr>
+        </p:nvSpPr>
+        <p:spPr>
+          <a:xfrm>
+            <a:off x="11155680" y="6355080"/>
+            <a:ext cx="548640" cy="274320"/>
+          </a:xfrm>
+          <a:prstGeom prst="rect">
+            <a:avLst/>
+          </a:prstGeom>
+          <a:extLst>
+            <a:ext uri="{C572A759-6A51-4108-AA02-DFA0A04FC94B}">
+              <ma14:wrappingTextBoxFlag xmlns:ma14="http://schemas.microsoft.com/office/mac/drawingml/2011/main" val="0"/>
+            </a:ext>
+          </a:extLst>
+        </p:spPr>
+        <p:txBody>
+          <a:bodyPr/>
+          <a:lstStyle>
+            <a:lvl1pPr>
+              <a:defRPr sz="1000">
+                <a:solidFill>
+                  <a:srgbClr val="6B7480"/>
+                </a:solidFill>
+              </a:defRPr>
+            </a:lvl1pPr>
+          </a:lstStyle>
+          <a:p>
+            <a:pPr algn="r"/>
+            <a:fld id="{F7021451-1387-4CA6-816F-3879F97B5CBC}" type="slidenum">
+              <a:rPr b="0" lang="en-US"/>
+              <a:t>25</a:t>
             </a:fld>
             <a:endParaRPr lang="en-US"/>
           </a:p>

</xml_diff>